<commit_message>
Add display-size ppi image compression (v1.3.0).
Co-authored-by: Cursor <cursoragent@cursor.com>
</commit_message>
<xml_diff>
--- a/test/fixtures/smoke-test.pptx
+++ b/test/fixtures/smoke-test.pptx
@@ -1,6 +1,7 @@
 
 <file path=ppt/presentation.xml><?xml version="1.0" encoding="utf-8"?>
 <p:presentation xmlns:p="http://schemas.openxmlformats.org/presentationml/2006/main" xmlns:r="http://schemas.openxmlformats.org/officeDocument/2006/relationships">
+  <p:sldSz cx="12192000" cy="6858000"/>
   <p:sldMasterIdLst>
     <p:sldMasterId id="1" r:id="rId3"/>
   </p:sldMasterIdLst>
@@ -20,7 +21,7 @@
 </file>
 
 <file path=ppt/slides/slide1.xml><?xml version="1.0" encoding="utf-8"?>
-<p:sld xmlns:p="http://schemas.openxmlformats.org/presentationml/2006/main" xmlns:a="http://schemas.openxmlformats.org/drawingml/2006/main">
+<p:sld xmlns:p="http://schemas.openxmlformats.org/presentationml/2006/main" xmlns:a="http://schemas.openxmlformats.org/drawingml/2006/main" xmlns:r="http://schemas.openxmlformats.org/officeDocument/2006/relationships">
   <p:cSld>
     <p:spTree>
       <p:sp>
@@ -57,6 +58,28 @@
           </a:p>
         </p:txBody>
       </p:sp>
+      <p:pic>
+        <p:nvPicPr>
+          <p:cNvPr id="3" name="Picture"/>
+          <p:cNvPicPr/>
+          <p:nvPr/>
+        </p:nvPicPr>
+        <p:blipFill>
+          <a:blip r:embed="rId2"/>
+          <a:stretch>
+            <a:fillRect/>
+          </a:stretch>
+        </p:blipFill>
+        <p:spPr>
+          <a:xfrm>
+            <a:off x="457200" y="2743200"/>
+            <a:ext cx="1828800" cy="1371600"/>
+          </a:xfrm>
+          <a:prstGeom prst="rect">
+            <a:avLst/>
+          </a:prstGeom>
+        </p:spPr>
+      </p:pic>
     </p:spTree>
   </p:cSld>
 </p:sld>

</xml_diff>